<commit_message>
Strengthen dual business/IT-InfoSec thesis in deck, add client Q&A prep sheet
Rework slides 2, 7, 8, 12 of the sales deck so the "one mechanism, two
beneficiaries" argument runs through the whole pitch instead of living
only on slide 7; soften the RBAC-inheritance claim and add pilot-ToR
caveats on slides 5 and 7 per the case-04 critique. Update the slide
breakdown (md+html) to match, with a new audience-navigation table.

Add client-qa-prep.md: a separate, not-in-the-deck sales sheet of
expected client questions and prepared answers, grounded in case-03's
AI Guard acceptance criteria and case-04's findings.
</commit_message>
<xml_diff>
--- a/docs/sales-enablement/presentation/korporativny-ai-sloy-prezentatsiya-tza-style.pptx
+++ b/docs/sales-enablement/presentation/korporativny-ai-sloy-prezentatsiya-tza-style.pptx
@@ -4222,6 +4222,68 @@
         </p:nvSpPr>
         <p:spPr>
           <a:xfrm>
+            <a:off x="640080" y="4526280"/>
+            <a:ext cx="411480" cy="29261"/>
+          </a:xfrm>
+          <a:prstGeom prst="rect">
+            <a:avLst/>
+          </a:prstGeom>
+          <a:solidFill>
+            <a:srgbClr val="E87A1E"/>
+          </a:solidFill>
+          <a:ln/>
+        </p:spPr>
+      </p:sp>
+      <p:sp>
+        <p:nvSpPr>
+          <p:cNvPr id="14" name="Text 12"/>
+          <p:cNvSpPr/>
+          <p:nvPr/>
+        </p:nvSpPr>
+        <p:spPr>
+          <a:xfrm>
+            <a:off x="640080" y="4709160"/>
+            <a:ext cx="6583680" cy="777240"/>
+          </a:xfrm>
+          <a:prstGeom prst="rect">
+            <a:avLst/>
+          </a:prstGeom>
+          <a:noFill/>
+          <a:ln/>
+        </p:spPr>
+        <p:txBody>
+          <a:bodyPr wrap="square" lIns="0" tIns="0" rIns="0" bIns="0" rtlCol="0" anchor="ctr"/>
+          <a:lstStyle/>
+          <a:p>
+            <a:pPr indent="0" marL="0">
+              <a:lnSpc>
+                <a:spcPct val="120000"/>
+              </a:lnSpc>
+              <a:buNone/>
+            </a:pPr>
+            <a:r>
+              <a:rPr lang="en-US" sz="1400" b="1" i="1" dirty="0">
+                <a:solidFill>
+                  <a:srgbClr val="C8D2DC"/>
+                </a:solidFill>
+                <a:latin typeface="Calibri" pitchFamily="34" charset="0"/>
+                <a:ea typeface="Calibri" pitchFamily="34" charset="-122"/>
+                <a:cs typeface="Calibri" pitchFamily="34" charset="-120"/>
+              </a:rPr>
+              <a:t>Один проект — предсказуемость для бизнеса и один управляемый периметр для ИТ и ИБ. Не два разных решения, а один слой с двумя результатами.</a:t>
+            </a:r>
+            <a:endParaRPr lang="en-US" sz="1400" dirty="0"/>
+          </a:p>
+        </p:txBody>
+      </p:sp>
+      <p:sp>
+        <p:nvSpPr>
+          <p:cNvPr id="15" name="Shape 13"/>
+          <p:cNvSpPr/>
+          <p:nvPr/>
+        </p:nvSpPr>
+        <p:spPr>
+          <a:xfrm>
             <a:off x="7543800" y="2194560"/>
             <a:ext cx="12802" cy="3291840"/>
           </a:xfrm>
@@ -4236,7 +4298,7 @@
       </p:sp>
       <p:sp>
         <p:nvSpPr>
-          <p:cNvPr id="14" name="Text 12"/>
+          <p:cNvPr id="16" name="Text 14"/>
           <p:cNvSpPr/>
           <p:nvPr/>
         </p:nvSpPr>
@@ -4275,7 +4337,7 @@
       </p:sp>
       <p:sp>
         <p:nvSpPr>
-          <p:cNvPr id="15" name="Text 13"/>
+          <p:cNvPr id="17" name="Text 15"/>
           <p:cNvSpPr/>
           <p:nvPr/>
         </p:nvSpPr>
@@ -4314,7 +4376,7 @@
       </p:sp>
       <p:sp>
         <p:nvSpPr>
-          <p:cNvPr id="16" name="Text 14"/>
+          <p:cNvPr id="18" name="Text 16"/>
           <p:cNvSpPr/>
           <p:nvPr/>
         </p:nvSpPr>
@@ -4353,7 +4415,7 @@
       </p:sp>
       <p:sp>
         <p:nvSpPr>
-          <p:cNvPr id="17" name="Text 15"/>
+          <p:cNvPr id="19" name="Text 17"/>
           <p:cNvSpPr/>
           <p:nvPr/>
         </p:nvSpPr>
@@ -4392,7 +4454,7 @@
       </p:sp>
       <p:sp>
         <p:nvSpPr>
-          <p:cNvPr id="18" name="Text 16"/>
+          <p:cNvPr id="20" name="Text 18"/>
           <p:cNvSpPr/>
           <p:nvPr/>
         </p:nvSpPr>
@@ -4431,7 +4493,7 @@
       </p:sp>
       <p:sp>
         <p:nvSpPr>
-          <p:cNvPr id="19" name="Text 17"/>
+          <p:cNvPr id="21" name="Text 19"/>
           <p:cNvSpPr/>
           <p:nvPr/>
         </p:nvSpPr>
@@ -4813,7 +4875,7 @@
                 <a:ea typeface="Calibri" pitchFamily="34" charset="-122"/>
                 <a:cs typeface="Calibri" pitchFamily="34" charset="-120"/>
               </a:rPr>
-              <a:t>«Сделайте нам ИИ»</a:t>
+              <a:t>Боль бизнеса — нет приоритетов</a:t>
             </a:r>
             <a:endParaRPr lang="en-US" sz="1300" dirty="0"/>
           </a:p>
@@ -4995,7 +5057,7 @@
                 <a:ea typeface="Calibri" pitchFamily="34" charset="-122"/>
                 <a:cs typeface="Calibri" pitchFamily="34" charset="-120"/>
               </a:rPr>
-              <a:t>Без общих правил</a:t>
+              <a:t>Риск для ИБ — теневой ИИ</a:t>
             </a:r>
             <a:endParaRPr lang="en-US" sz="1300" dirty="0"/>
           </a:p>
@@ -5197,7 +5259,7 @@
                 <a:ea typeface="Calibri" pitchFamily="34" charset="-122"/>
                 <a:cs typeface="Calibri" pitchFamily="34" charset="-120"/>
               </a:rPr>
-              <a:t>Запросов всё больше</a:t>
+              <a:t>Трение — и ИТ, и бизнесу</a:t>
             </a:r>
             <a:endParaRPr lang="en-US" sz="1300" dirty="0"/>
           </a:p>
@@ -8332,7 +8394,7 @@
                 <a:ea typeface="Calibri" pitchFamily="34" charset="-122"/>
                 <a:cs typeface="Calibri" pitchFamily="34" charset="-120"/>
               </a:rPr>
-              <a:t>Ролевая модель (RBAC) наследуется из систем-источников</a:t>
+              <a:t>RBAC синхронизируется с системами-источниками; состав ролей согласуется на старте</a:t>
             </a:r>
             <a:endParaRPr lang="en-US" sz="1150" dirty="0"/>
           </a:p>
@@ -8617,7 +8679,7 @@
         </p:nvSpPr>
         <p:spPr>
           <a:xfrm>
-            <a:off x="640080" y="6263640"/>
+            <a:off x="640080" y="5943600"/>
             <a:ext cx="10607040" cy="548640"/>
           </a:xfrm>
           <a:prstGeom prst="rect">
@@ -8645,7 +8707,7 @@
                 <a:ea typeface="Calibri" pitchFamily="34" charset="-122"/>
                 <a:cs typeface="Calibri" pitchFamily="34" charset="-120"/>
               </a:rPr>
-              <a:t>Новый сценарий = ваша специфика + готовая обвязка. Поэтому запуск занимает недели, а не месяцы.</a:t>
+              <a:t>Новый сценарий = специфика клиента + готовая обвязка — недели, а не месяцы. Точный % маскирования и состав ролей согласуются на старте по пилотному ТЗ.</a:t>
             </a:r>
             <a:endParaRPr lang="en-US" sz="1250" dirty="0"/>
           </a:p>
@@ -9852,7 +9914,7 @@
                 <a:ea typeface="Calibri" pitchFamily="34" charset="-122"/>
                 <a:cs typeface="Calibri" pitchFamily="34" charset="-120"/>
               </a:rPr>
-              <a:t>Бизнесу — конвейер, ИТ — управляемость</a:t>
+              <a:t>Один механизм — два результата одновременно</a:t>
             </a:r>
             <a:endParaRPr lang="en-US" sz="3000" dirty="0"/>
           </a:p>
@@ -9914,7 +9976,7 @@
                 <a:ea typeface="Calibri" pitchFamily="34" charset="-122"/>
                 <a:cs typeface="Calibri" pitchFamily="34" charset="-120"/>
               </a:rPr>
-              <a:t>Один контур одновременно закрывает две повестки, которые обычно конфликтуют: скорость бизнеса и контроль ИТ и ИБ.</a:t>
+              <a:t>Это не два разных бонуса, а одно устройство контура с двумя эффектами: то, что снимает нагрузку с ИТ и ИБ, — то же самое, что делает путь идеи для бизнеса предсказуемым.</a:t>
             </a:r>
             <a:endParaRPr lang="en-US" sz="1350" dirty="0"/>
           </a:p>
@@ -9928,24 +9990,102 @@
         </p:nvSpPr>
         <p:spPr>
           <a:xfrm>
-            <a:off x="640080" y="2377440"/>
-            <a:ext cx="5074920" cy="365760"/>
-          </a:xfrm>
-          <a:prstGeom prst="rect">
-            <a:avLst/>
-          </a:prstGeom>
-          <a:noFill/>
-          <a:ln/>
-        </p:spPr>
-        <p:txBody>
-          <a:bodyPr wrap="square" lIns="0" tIns="0" rIns="0" bIns="0" rtlCol="0" anchor="ctr"/>
-          <a:lstStyle/>
-          <a:p>
-            <a:pPr indent="0" marL="0">
-              <a:buNone/>
-            </a:pPr>
-            <a:r>
-              <a:rPr lang="en-US" sz="1800" b="1" dirty="0">
+            <a:off x="640080" y="2331720"/>
+            <a:ext cx="2743200" cy="274320"/>
+          </a:xfrm>
+          <a:prstGeom prst="rect">
+            <a:avLst/>
+          </a:prstGeom>
+          <a:noFill/>
+          <a:ln/>
+        </p:spPr>
+        <p:txBody>
+          <a:bodyPr wrap="square" lIns="0" tIns="0" rIns="0" bIns="0" rtlCol="0" anchor="ctr"/>
+          <a:lstStyle/>
+          <a:p>
+            <a:pPr indent="0" marL="0">
+              <a:buNone/>
+            </a:pPr>
+            <a:r>
+              <a:rPr lang="en-US" sz="1100" b="1" dirty="0">
+                <a:solidFill>
+                  <a:srgbClr val="B8BEC6"/>
+                </a:solidFill>
+                <a:latin typeface="Calibri" pitchFamily="34" charset="0"/>
+                <a:ea typeface="Calibri" pitchFamily="34" charset="-122"/>
+                <a:cs typeface="Calibri" pitchFamily="34" charset="-120"/>
+              </a:rPr>
+              <a:t>МЕХАНИЗМ</a:t>
+            </a:r>
+            <a:endParaRPr lang="en-US" sz="1100" dirty="0"/>
+          </a:p>
+        </p:txBody>
+      </p:sp>
+      <p:sp>
+        <p:nvSpPr>
+          <p:cNvPr id="8" name="Text 6"/>
+          <p:cNvSpPr/>
+          <p:nvPr/>
+        </p:nvSpPr>
+        <p:spPr>
+          <a:xfrm>
+            <a:off x="3657600" y="2331720"/>
+            <a:ext cx="3794760" cy="274320"/>
+          </a:xfrm>
+          <a:prstGeom prst="rect">
+            <a:avLst/>
+          </a:prstGeom>
+          <a:noFill/>
+          <a:ln/>
+        </p:spPr>
+        <p:txBody>
+          <a:bodyPr wrap="square" lIns="0" tIns="0" rIns="0" bIns="0" rtlCol="0" anchor="ctr"/>
+          <a:lstStyle/>
+          <a:p>
+            <a:pPr indent="0" marL="0">
+              <a:buNone/>
+            </a:pPr>
+            <a:r>
+              <a:rPr lang="en-US" sz="1100" b="1" dirty="0">
+                <a:solidFill>
+                  <a:srgbClr val="E87A1E"/>
+                </a:solidFill>
+                <a:latin typeface="Calibri" pitchFamily="34" charset="0"/>
+                <a:ea typeface="Calibri" pitchFamily="34" charset="-122"/>
+                <a:cs typeface="Calibri" pitchFamily="34" charset="-120"/>
+              </a:rPr>
+              <a:t>ПОЛУЧАЕТ БИЗНЕС</a:t>
+            </a:r>
+            <a:endParaRPr lang="en-US" sz="1100" dirty="0"/>
+          </a:p>
+        </p:txBody>
+      </p:sp>
+      <p:sp>
+        <p:nvSpPr>
+          <p:cNvPr id="9" name="Text 7"/>
+          <p:cNvSpPr/>
+          <p:nvPr/>
+        </p:nvSpPr>
+        <p:spPr>
+          <a:xfrm>
+            <a:off x="7726680" y="2331720"/>
+            <a:ext cx="3520440" cy="274320"/>
+          </a:xfrm>
+          <a:prstGeom prst="rect">
+            <a:avLst/>
+          </a:prstGeom>
+          <a:noFill/>
+          <a:ln/>
+        </p:spPr>
+        <p:txBody>
+          <a:bodyPr wrap="square" lIns="0" tIns="0" rIns="0" bIns="0" rtlCol="0" anchor="ctr"/>
+          <a:lstStyle/>
+          <a:p>
+            <a:pPr indent="0" marL="0">
+              <a:buNone/>
+            </a:pPr>
+            <a:r>
+              <a:rPr lang="en-US" sz="1100" b="1" dirty="0">
                 <a:solidFill>
                   <a:srgbClr val="0F2A4A"/>
                 </a:solidFill>
@@ -9953,71 +10093,9 @@
                 <a:ea typeface="Calibri" pitchFamily="34" charset="-122"/>
                 <a:cs typeface="Calibri" pitchFamily="34" charset="-120"/>
               </a:rPr>
-              <a:t>Бизнесу — конвейер</a:t>
-            </a:r>
-            <a:endParaRPr lang="en-US" sz="1800" dirty="0"/>
-          </a:p>
-        </p:txBody>
-      </p:sp>
-      <p:sp>
-        <p:nvSpPr>
-          <p:cNvPr id="8" name="Shape 6"/>
-          <p:cNvSpPr/>
-          <p:nvPr/>
-        </p:nvSpPr>
-        <p:spPr>
-          <a:xfrm>
-            <a:off x="640080" y="2779776"/>
-            <a:ext cx="411480" cy="29261"/>
-          </a:xfrm>
-          <a:prstGeom prst="rect">
-            <a:avLst/>
-          </a:prstGeom>
-          <a:solidFill>
-            <a:srgbClr val="E87A1E"/>
-          </a:solidFill>
-          <a:ln/>
-        </p:spPr>
-      </p:sp>
-      <p:sp>
-        <p:nvSpPr>
-          <p:cNvPr id="9" name="Text 7"/>
-          <p:cNvSpPr/>
-          <p:nvPr/>
-        </p:nvSpPr>
-        <p:spPr>
-          <a:xfrm>
-            <a:off x="640080" y="3063240"/>
-            <a:ext cx="5074920" cy="475488"/>
-          </a:xfrm>
-          <a:prstGeom prst="rect">
-            <a:avLst/>
-          </a:prstGeom>
-          <a:noFill/>
-          <a:ln/>
-        </p:spPr>
-        <p:txBody>
-          <a:bodyPr wrap="square" lIns="0" tIns="0" rIns="0" bIns="0" rtlCol="0" anchor="ctr"/>
-          <a:lstStyle/>
-          <a:p>
-            <a:pPr indent="0" marL="0">
-              <a:lnSpc>
-                <a:spcPct val="118000"/>
-              </a:lnSpc>
-              <a:buNone/>
-            </a:pPr>
-            <a:r>
-              <a:rPr lang="en-US" sz="1300" dirty="0">
-                <a:solidFill>
-                  <a:srgbClr val="555B66"/>
-                </a:solidFill>
-                <a:latin typeface="Calibri" pitchFamily="34" charset="0"/>
-                <a:ea typeface="Calibri" pitchFamily="34" charset="-122"/>
-                <a:cs typeface="Calibri" pitchFamily="34" charset="-120"/>
-              </a:rPr>
-              <a:t>Понятный путь идеи: от формулировки до прода за известный срок.</a:t>
-            </a:r>
-            <a:endParaRPr lang="en-US" sz="1300" dirty="0"/>
+              <a:t>ПОЛУЧАЮТ ИТ И ИБ</a:t>
+            </a:r>
+            <a:endParaRPr lang="en-US" sz="1100" dirty="0"/>
           </a:p>
         </p:txBody>
       </p:sp>
@@ -10029,8 +10107,8 @@
         </p:nvSpPr>
         <p:spPr>
           <a:xfrm>
-            <a:off x="640080" y="3602736"/>
-            <a:ext cx="5074920" cy="10973"/>
+            <a:off x="640080" y="2642616"/>
+            <a:ext cx="10607040" cy="10973"/>
           </a:xfrm>
           <a:prstGeom prst="rect">
             <a:avLst/>
@@ -10049,8 +10127,8 @@
         </p:nvSpPr>
         <p:spPr>
           <a:xfrm>
-            <a:off x="640080" y="3675888"/>
-            <a:ext cx="5074920" cy="475488"/>
+            <a:off x="640080" y="2834640"/>
+            <a:ext cx="2743200" cy="630936"/>
           </a:xfrm>
           <a:prstGeom prst="rect">
             <a:avLst/>
@@ -10064,12 +10142,54 @@
           <a:p>
             <a:pPr indent="0" marL="0">
               <a:lnSpc>
-                <a:spcPct val="118000"/>
+                <a:spcPct val="115000"/>
               </a:lnSpc>
               <a:buNone/>
             </a:pPr>
             <a:r>
-              <a:rPr lang="en-US" sz="1300" dirty="0">
+              <a:rPr lang="en-US" sz="1200" b="1" dirty="0">
+                <a:solidFill>
+                  <a:srgbClr val="0F2A4A"/>
+                </a:solidFill>
+                <a:latin typeface="Calibri" pitchFamily="34" charset="0"/>
+                <a:ea typeface="Calibri" pitchFamily="34" charset="-122"/>
+                <a:cs typeface="Calibri" pitchFamily="34" charset="-120"/>
+              </a:rPr>
+              <a:t>Единый периметр безопасности: одна политика на все сценарии.</a:t>
+            </a:r>
+            <a:endParaRPr lang="en-US" sz="1200" dirty="0"/>
+          </a:p>
+        </p:txBody>
+      </p:sp>
+      <p:sp>
+        <p:nvSpPr>
+          <p:cNvPr id="12" name="Text 10"/>
+          <p:cNvSpPr/>
+          <p:nvPr/>
+        </p:nvSpPr>
+        <p:spPr>
+          <a:xfrm>
+            <a:off x="3657600" y="2834640"/>
+            <a:ext cx="3794760" cy="630936"/>
+          </a:xfrm>
+          <a:prstGeom prst="rect">
+            <a:avLst/>
+          </a:prstGeom>
+          <a:noFill/>
+          <a:ln/>
+        </p:spPr>
+        <p:txBody>
+          <a:bodyPr wrap="square" lIns="0" tIns="0" rIns="0" bIns="0" rtlCol="0" anchor="ctr"/>
+          <a:lstStyle/>
+          <a:p>
+            <a:pPr indent="0" marL="0">
+              <a:lnSpc>
+                <a:spcPct val="115000"/>
+              </a:lnSpc>
+              <a:buNone/>
+            </a:pPr>
+            <a:r>
+              <a:rPr lang="en-US" sz="1200" dirty="0">
                 <a:solidFill>
                   <a:srgbClr val="555B66"/>
                 </a:solidFill>
@@ -10077,22 +10197,64 @@
                 <a:ea typeface="Calibri" pitchFamily="34" charset="-122"/>
                 <a:cs typeface="Calibri" pitchFamily="34" charset="-120"/>
               </a:rPr>
-              <a:t>ИИ из набора экспериментов превращается в управляемую деятельность.</a:t>
-            </a:r>
-            <a:endParaRPr lang="en-US" sz="1300" dirty="0"/>
-          </a:p>
-        </p:txBody>
-      </p:sp>
-      <p:sp>
-        <p:nvSpPr>
-          <p:cNvPr id="12" name="Shape 10"/>
-          <p:cNvSpPr/>
-          <p:nvPr/>
-        </p:nvSpPr>
-        <p:spPr>
-          <a:xfrm>
-            <a:off x="640080" y="4215384"/>
-            <a:ext cx="5074920" cy="10973"/>
+              <a:t>Идея не зависает на согласовании с ИБ заново — путь от формулировки до прода известен заранее.</a:t>
+            </a:r>
+            <a:endParaRPr lang="en-US" sz="1200" dirty="0"/>
+          </a:p>
+        </p:txBody>
+      </p:sp>
+      <p:sp>
+        <p:nvSpPr>
+          <p:cNvPr id="13" name="Text 11"/>
+          <p:cNvSpPr/>
+          <p:nvPr/>
+        </p:nvSpPr>
+        <p:spPr>
+          <a:xfrm>
+            <a:off x="7726680" y="2834640"/>
+            <a:ext cx="3520440" cy="630936"/>
+          </a:xfrm>
+          <a:prstGeom prst="rect">
+            <a:avLst/>
+          </a:prstGeom>
+          <a:noFill/>
+          <a:ln/>
+        </p:spPr>
+        <p:txBody>
+          <a:bodyPr wrap="square" lIns="0" tIns="0" rIns="0" bIns="0" rtlCol="0" anchor="ctr"/>
+          <a:lstStyle/>
+          <a:p>
+            <a:pPr indent="0" marL="0">
+              <a:lnSpc>
+                <a:spcPct val="115000"/>
+              </a:lnSpc>
+              <a:buNone/>
+            </a:pPr>
+            <a:r>
+              <a:rPr lang="en-US" sz="1200" dirty="0">
+                <a:solidFill>
+                  <a:srgbClr val="555B66"/>
+                </a:solidFill>
+                <a:latin typeface="Calibri" pitchFamily="34" charset="0"/>
+                <a:ea typeface="Calibri" pitchFamily="34" charset="-122"/>
+                <a:cs typeface="Calibri" pitchFamily="34" charset="-120"/>
+              </a:rPr>
+              <a:t>Один периметр и одна политика вместо согласования каждого нового сценария с нуля.</a:t>
+            </a:r>
+            <a:endParaRPr lang="en-US" sz="1200" dirty="0"/>
+          </a:p>
+        </p:txBody>
+      </p:sp>
+      <p:sp>
+        <p:nvSpPr>
+          <p:cNvPr id="14" name="Shape 12"/>
+          <p:cNvSpPr/>
+          <p:nvPr/>
+        </p:nvSpPr>
+        <p:spPr>
+          <a:xfrm>
+            <a:off x="640080" y="3593592"/>
+            <a:ext cx="10607040" cy="10973"/>
           </a:xfrm>
           <a:prstGeom prst="rect">
             <a:avLst/>
@@ -10105,14 +10267,14 @@
       </p:sp>
       <p:sp>
         <p:nvSpPr>
-          <p:cNvPr id="13" name="Text 11"/>
-          <p:cNvSpPr/>
-          <p:nvPr/>
-        </p:nvSpPr>
-        <p:spPr>
-          <a:xfrm>
-            <a:off x="640080" y="4288536"/>
-            <a:ext cx="5074920" cy="475488"/>
+          <p:cNvPr id="15" name="Text 13"/>
+          <p:cNvSpPr/>
+          <p:nvPr/>
+        </p:nvSpPr>
+        <p:spPr>
+          <a:xfrm>
+            <a:off x="640080" y="3721608"/>
+            <a:ext cx="2743200" cy="630936"/>
           </a:xfrm>
           <a:prstGeom prst="rect">
             <a:avLst/>
@@ -10126,12 +10288,54 @@
           <a:p>
             <a:pPr indent="0" marL="0">
               <a:lnSpc>
-                <a:spcPct val="118000"/>
+                <a:spcPct val="115000"/>
               </a:lnSpc>
               <a:buNone/>
             </a:pPr>
             <a:r>
-              <a:rPr lang="en-US" sz="1300" dirty="0">
+              <a:rPr lang="en-US" sz="1200" b="1" dirty="0">
+                <a:solidFill>
+                  <a:srgbClr val="0F2A4A"/>
+                </a:solidFill>
+                <a:latin typeface="Calibri" pitchFamily="34" charset="0"/>
+                <a:ea typeface="Calibri" pitchFamily="34" charset="-122"/>
+                <a:cs typeface="Calibri" pitchFamily="34" charset="-120"/>
+              </a:rPr>
+              <a:t>Единый governance: доступы, аудит, жизненный цикл моделей — в одной системе.</a:t>
+            </a:r>
+            <a:endParaRPr lang="en-US" sz="1200" dirty="0"/>
+          </a:p>
+        </p:txBody>
+      </p:sp>
+      <p:sp>
+        <p:nvSpPr>
+          <p:cNvPr id="16" name="Text 14"/>
+          <p:cNvSpPr/>
+          <p:nvPr/>
+        </p:nvSpPr>
+        <p:spPr>
+          <a:xfrm>
+            <a:off x="3657600" y="3721608"/>
+            <a:ext cx="3794760" cy="630936"/>
+          </a:xfrm>
+          <a:prstGeom prst="rect">
+            <a:avLst/>
+          </a:prstGeom>
+          <a:noFill/>
+          <a:ln/>
+        </p:spPr>
+        <p:txBody>
+          <a:bodyPr wrap="square" lIns="0" tIns="0" rIns="0" bIns="0" rtlCol="0" anchor="ctr"/>
+          <a:lstStyle/>
+          <a:p>
+            <a:pPr indent="0" marL="0">
+              <a:lnSpc>
+                <a:spcPct val="115000"/>
+              </a:lnSpc>
+              <a:buNone/>
+            </a:pPr>
+            <a:r>
+              <a:rPr lang="en-US" sz="1200" dirty="0">
                 <a:solidFill>
                   <a:srgbClr val="555B66"/>
                 </a:solidFill>
@@ -10139,81 +10343,22 @@
                 <a:ea typeface="Calibri" pitchFamily="34" charset="-122"/>
                 <a:cs typeface="Calibri" pitchFamily="34" charset="-120"/>
               </a:rPr>
-              <a:t>Владельцы процессов приходят с идеями, а не ждут «ИТ что-нибудь сделает».</a:t>
-            </a:r>
-            <a:endParaRPr lang="en-US" sz="1300" dirty="0"/>
-          </a:p>
-        </p:txBody>
-      </p:sp>
-      <p:sp>
-        <p:nvSpPr>
-          <p:cNvPr id="14" name="Text 12"/>
-          <p:cNvSpPr/>
-          <p:nvPr/>
-        </p:nvSpPr>
-        <p:spPr>
-          <a:xfrm>
-            <a:off x="6172200" y="2377440"/>
-            <a:ext cx="5074920" cy="365760"/>
-          </a:xfrm>
-          <a:prstGeom prst="rect">
-            <a:avLst/>
-          </a:prstGeom>
-          <a:noFill/>
-          <a:ln/>
-        </p:spPr>
-        <p:txBody>
-          <a:bodyPr wrap="square" lIns="0" tIns="0" rIns="0" bIns="0" rtlCol="0" anchor="ctr"/>
-          <a:lstStyle/>
-          <a:p>
-            <a:pPr indent="0" marL="0">
-              <a:buNone/>
-            </a:pPr>
-            <a:r>
-              <a:rPr lang="en-US" sz="1800" b="1" dirty="0">
-                <a:solidFill>
-                  <a:srgbClr val="0F2A4A"/>
-                </a:solidFill>
-                <a:latin typeface="Calibri" pitchFamily="34" charset="0"/>
-                <a:ea typeface="Calibri" pitchFamily="34" charset="-122"/>
-                <a:cs typeface="Calibri" pitchFamily="34" charset="-120"/>
-              </a:rPr>
-              <a:t>ИТ и ИБ — управляемость</a:t>
-            </a:r>
-            <a:endParaRPr lang="en-US" sz="1800" dirty="0"/>
-          </a:p>
-        </p:txBody>
-      </p:sp>
-      <p:sp>
-        <p:nvSpPr>
-          <p:cNvPr id="15" name="Shape 13"/>
-          <p:cNvSpPr/>
-          <p:nvPr/>
-        </p:nvSpPr>
-        <p:spPr>
-          <a:xfrm>
-            <a:off x="6172200" y="2779776"/>
-            <a:ext cx="411480" cy="29261"/>
-          </a:xfrm>
-          <a:prstGeom prst="rect">
-            <a:avLst/>
-          </a:prstGeom>
-          <a:solidFill>
-            <a:srgbClr val="0F2A4A"/>
-          </a:solidFill>
-          <a:ln/>
-        </p:spPr>
-      </p:sp>
-      <p:sp>
-        <p:nvSpPr>
-          <p:cNvPr id="16" name="Text 14"/>
-          <p:cNvSpPr/>
-          <p:nvPr/>
-        </p:nvSpPr>
-        <p:spPr>
-          <a:xfrm>
-            <a:off x="6172200" y="3063240"/>
-            <a:ext cx="5074920" cy="475488"/>
+              <a:t>Владельцы процессов приходят с идеями, а не ждут, пока «ИТ что-нибудь сделает».</a:t>
+            </a:r>
+            <a:endParaRPr lang="en-US" sz="1200" dirty="0"/>
+          </a:p>
+        </p:txBody>
+      </p:sp>
+      <p:sp>
+        <p:nvSpPr>
+          <p:cNvPr id="17" name="Text 15"/>
+          <p:cNvSpPr/>
+          <p:nvPr/>
+        </p:nvSpPr>
+        <p:spPr>
+          <a:xfrm>
+            <a:off x="7726680" y="3721608"/>
+            <a:ext cx="3520440" cy="630936"/>
           </a:xfrm>
           <a:prstGeom prst="rect">
             <a:avLst/>
@@ -10227,12 +10372,12 @@
           <a:p>
             <a:pPr indent="0" marL="0">
               <a:lnSpc>
-                <a:spcPct val="118000"/>
+                <a:spcPct val="115000"/>
               </a:lnSpc>
               <a:buNone/>
             </a:pPr>
             <a:r>
-              <a:rPr lang="en-US" sz="1300" dirty="0">
+              <a:rPr lang="en-US" sz="1200" dirty="0">
                 <a:solidFill>
                   <a:srgbClr val="555B66"/>
                 </a:solidFill>
@@ -10240,22 +10385,22 @@
                 <a:ea typeface="Calibri" pitchFamily="34" charset="-122"/>
                 <a:cs typeface="Calibri" pitchFamily="34" charset="-120"/>
               </a:rPr>
-              <a:t>Единый периметр безопасности: одна политика на все сценарии.</a:t>
-            </a:r>
-            <a:endParaRPr lang="en-US" sz="1300" dirty="0"/>
-          </a:p>
-        </p:txBody>
-      </p:sp>
-      <p:sp>
-        <p:nvSpPr>
-          <p:cNvPr id="17" name="Shape 15"/>
-          <p:cNvSpPr/>
-          <p:nvPr/>
-        </p:nvSpPr>
-        <p:spPr>
-          <a:xfrm>
-            <a:off x="6172200" y="3602736"/>
-            <a:ext cx="5074920" cy="10973"/>
+              <a:t>Доступы и аудит контролируются централизованно, а не вручную по каждому сценарию.</a:t>
+            </a:r>
+            <a:endParaRPr lang="en-US" sz="1200" dirty="0"/>
+          </a:p>
+        </p:txBody>
+      </p:sp>
+      <p:sp>
+        <p:nvSpPr>
+          <p:cNvPr id="18" name="Shape 16"/>
+          <p:cNvSpPr/>
+          <p:nvPr/>
+        </p:nvSpPr>
+        <p:spPr>
+          <a:xfrm>
+            <a:off x="640080" y="4480560"/>
+            <a:ext cx="10607040" cy="10973"/>
           </a:xfrm>
           <a:prstGeom prst="rect">
             <a:avLst/>
@@ -10268,14 +10413,14 @@
       </p:sp>
       <p:sp>
         <p:nvSpPr>
-          <p:cNvPr id="18" name="Text 16"/>
-          <p:cNvSpPr/>
-          <p:nvPr/>
-        </p:nvSpPr>
-        <p:spPr>
-          <a:xfrm>
-            <a:off x="6172200" y="3675888"/>
-            <a:ext cx="5074920" cy="475488"/>
+          <p:cNvPr id="19" name="Text 17"/>
+          <p:cNvSpPr/>
+          <p:nvPr/>
+        </p:nvSpPr>
+        <p:spPr>
+          <a:xfrm>
+            <a:off x="640080" y="4608576"/>
+            <a:ext cx="2743200" cy="630936"/>
           </a:xfrm>
           <a:prstGeom prst="rect">
             <a:avLst/>
@@ -10289,12 +10434,54 @@
           <a:p>
             <a:pPr indent="0" marL="0">
               <a:lnSpc>
-                <a:spcPct val="118000"/>
+                <a:spcPct val="115000"/>
               </a:lnSpc>
               <a:buNone/>
             </a:pPr>
             <a:r>
-              <a:rPr lang="en-US" sz="1300" dirty="0">
+              <a:rPr lang="en-US" sz="1200" b="1" dirty="0">
+                <a:solidFill>
+                  <a:srgbClr val="0F2A4A"/>
+                </a:solidFill>
+                <a:latin typeface="Calibri" pitchFamily="34" charset="0"/>
+                <a:ea typeface="Calibri" pitchFamily="34" charset="-122"/>
+                <a:cs typeface="Calibri" pitchFamily="34" charset="-120"/>
+              </a:rPr>
+              <a:t>Выделенная эксплуатация: SLA, обновления, разбор инцидентов.</a:t>
+            </a:r>
+            <a:endParaRPr lang="en-US" sz="1200" dirty="0"/>
+          </a:p>
+        </p:txBody>
+      </p:sp>
+      <p:sp>
+        <p:nvSpPr>
+          <p:cNvPr id="20" name="Text 18"/>
+          <p:cNvSpPr/>
+          <p:nvPr/>
+        </p:nvSpPr>
+        <p:spPr>
+          <a:xfrm>
+            <a:off x="3657600" y="4608576"/>
+            <a:ext cx="3794760" cy="630936"/>
+          </a:xfrm>
+          <a:prstGeom prst="rect">
+            <a:avLst/>
+          </a:prstGeom>
+          <a:noFill/>
+          <a:ln/>
+        </p:spPr>
+        <p:txBody>
+          <a:bodyPr wrap="square" lIns="0" tIns="0" rIns="0" bIns="0" rtlCol="0" anchor="ctr"/>
+          <a:lstStyle/>
+          <a:p>
+            <a:pPr indent="0" marL="0">
+              <a:lnSpc>
+                <a:spcPct val="115000"/>
+              </a:lnSpc>
+              <a:buNone/>
+            </a:pPr>
+            <a:r>
+              <a:rPr lang="en-US" sz="1200" dirty="0">
                 <a:solidFill>
                   <a:srgbClr val="555B66"/>
                 </a:solidFill>
@@ -10302,42 +10489,22 @@
                 <a:ea typeface="Calibri" pitchFamily="34" charset="-122"/>
                 <a:cs typeface="Calibri" pitchFamily="34" charset="-120"/>
               </a:rPr>
-              <a:t>Единый governance: доступы, аудит, жизненный цикл моделей — в одной системе.</a:t>
-            </a:r>
-            <a:endParaRPr lang="en-US" sz="1300" dirty="0"/>
-          </a:p>
-        </p:txBody>
-      </p:sp>
-      <p:sp>
-        <p:nvSpPr>
-          <p:cNvPr id="19" name="Shape 17"/>
-          <p:cNvSpPr/>
-          <p:nvPr/>
-        </p:nvSpPr>
-        <p:spPr>
-          <a:xfrm>
-            <a:off x="6172200" y="4215384"/>
-            <a:ext cx="5074920" cy="10973"/>
-          </a:xfrm>
-          <a:prstGeom prst="rect">
-            <a:avLst/>
-          </a:prstGeom>
-          <a:solidFill>
-            <a:srgbClr val="E2E5E9"/>
-          </a:solidFill>
-          <a:ln/>
-        </p:spPr>
-      </p:sp>
-      <p:sp>
-        <p:nvSpPr>
-          <p:cNvPr id="20" name="Text 18"/>
-          <p:cNvSpPr/>
-          <p:nvPr/>
-        </p:nvSpPr>
-        <p:spPr>
-          <a:xfrm>
-            <a:off x="6172200" y="4288536"/>
-            <a:ext cx="5074920" cy="475488"/>
+              <a:t>ИИ из набора экспериментов становится управляемой, предсказуемой деятельностью.</a:t>
+            </a:r>
+            <a:endParaRPr lang="en-US" sz="1200" dirty="0"/>
+          </a:p>
+        </p:txBody>
+      </p:sp>
+      <p:sp>
+        <p:nvSpPr>
+          <p:cNvPr id="21" name="Text 19"/>
+          <p:cNvSpPr/>
+          <p:nvPr/>
+        </p:nvSpPr>
+        <p:spPr>
+          <a:xfrm>
+            <a:off x="7726680" y="4608576"/>
+            <a:ext cx="3520440" cy="630936"/>
           </a:xfrm>
           <a:prstGeom prst="rect">
             <a:avLst/>
@@ -10351,12 +10518,12 @@
           <a:p>
             <a:pPr indent="0" marL="0">
               <a:lnSpc>
-                <a:spcPct val="118000"/>
+                <a:spcPct val="115000"/>
               </a:lnSpc>
               <a:buNone/>
             </a:pPr>
             <a:r>
-              <a:rPr lang="en-US" sz="1300" dirty="0">
+              <a:rPr lang="en-US" sz="1200" dirty="0">
                 <a:solidFill>
                   <a:srgbClr val="555B66"/>
                 </a:solidFill>
@@ -10364,31 +10531,53 @@
                 <a:ea typeface="Calibri" pitchFamily="34" charset="-122"/>
                 <a:cs typeface="Calibri" pitchFamily="34" charset="-120"/>
               </a:rPr>
-              <a:t>Выделенная эксплуатация: SLA, обновления, разбор инцидентов.</a:t>
-            </a:r>
-            <a:endParaRPr lang="en-US" sz="1300" dirty="0"/>
-          </a:p>
-        </p:txBody>
-      </p:sp>
-      <p:sp>
-        <p:nvSpPr>
-          <p:cNvPr id="21" name="Shape 19"/>
-          <p:cNvSpPr/>
-          <p:nvPr/>
-        </p:nvSpPr>
-        <p:spPr>
-          <a:xfrm>
-            <a:off x="5943600" y="2377440"/>
-            <a:ext cx="12802" cy="3291840"/>
-          </a:xfrm>
-          <a:prstGeom prst="rect">
-            <a:avLst/>
-          </a:prstGeom>
-          <a:solidFill>
-            <a:srgbClr val="E2E5E9"/>
-          </a:solidFill>
-          <a:ln/>
-        </p:spPr>
+              <a:t>Инциденты и обновления обрабатывает одна команда эксплуатации, а не россыпь пилотов.</a:t>
+            </a:r>
+            <a:endParaRPr lang="en-US" sz="1200" dirty="0"/>
+          </a:p>
+        </p:txBody>
+      </p:sp>
+      <p:sp>
+        <p:nvSpPr>
+          <p:cNvPr id="22" name="Text 20"/>
+          <p:cNvSpPr/>
+          <p:nvPr/>
+        </p:nvSpPr>
+        <p:spPr>
+          <a:xfrm>
+            <a:off x="640080" y="5632704"/>
+            <a:ext cx="10607040" cy="548640"/>
+          </a:xfrm>
+          <a:prstGeom prst="rect">
+            <a:avLst/>
+          </a:prstGeom>
+          <a:noFill/>
+          <a:ln/>
+        </p:spPr>
+        <p:txBody>
+          <a:bodyPr wrap="square" lIns="0" tIns="0" rIns="0" bIns="0" rtlCol="0" anchor="ctr"/>
+          <a:lstStyle/>
+          <a:p>
+            <a:pPr indent="0" marL="0">
+              <a:lnSpc>
+                <a:spcPct val="115000"/>
+              </a:lnSpc>
+              <a:buNone/>
+            </a:pPr>
+            <a:r>
+              <a:rPr lang="en-US" sz="1250" i="1" dirty="0">
+                <a:solidFill>
+                  <a:srgbClr val="555B66"/>
+                </a:solidFill>
+                <a:latin typeface="Calibri" pitchFamily="34" charset="0"/>
+                <a:ea typeface="Calibri" pitchFamily="34" charset="-122"/>
+                <a:cs typeface="Calibri" pitchFamily="34" charset="-120"/>
+              </a:rPr>
+              <a:t>Точный состав ролей и % маскирования, стоящие за «единой политикой», согласуются на старте проекта по пилотному ТЗ — см. также слайд 5.</a:t>
+            </a:r>
+            <a:endParaRPr lang="en-US" sz="1250" dirty="0"/>
+          </a:p>
+        </p:txBody>
       </p:sp>
     </p:spTree>
   </p:cSld>
@@ -10788,6 +10977,49 @@
       <p:sp>
         <p:nvSpPr>
           <p:cNvPr id="12" name="Text 9"/>
+          <p:cNvSpPr/>
+          <p:nvPr/>
+        </p:nvSpPr>
+        <p:spPr>
+          <a:xfrm>
+            <a:off x="6949440" y="4828032"/>
+            <a:ext cx="4023360" cy="950976"/>
+          </a:xfrm>
+          <a:prstGeom prst="rect">
+            <a:avLst/>
+          </a:prstGeom>
+          <a:noFill/>
+          <a:ln/>
+        </p:spPr>
+        <p:txBody>
+          <a:bodyPr wrap="square" lIns="0" tIns="0" rIns="0" bIns="0" rtlCol="0" anchor="ctr"/>
+          <a:lstStyle/>
+          <a:p>
+            <a:pPr marL="152400" indent="-152400">
+              <a:lnSpc>
+                <a:spcPct val="115000"/>
+              </a:lnSpc>
+              <a:buSzPct val="100000"/>
+              <a:buChar char="•"/>
+            </a:pPr>
+            <a:r>
+              <a:rPr lang="en-US" sz="1300" dirty="0">
+                <a:solidFill>
+                  <a:srgbClr val="555B66"/>
+                </a:solidFill>
+                <a:latin typeface="Calibri" pitchFamily="34" charset="0"/>
+                <a:ea typeface="Calibri" pitchFamily="34" charset="-122"/>
+                <a:cs typeface="Calibri" pitchFamily="34" charset="-120"/>
+              </a:rPr>
+              <a:t>Падает не только цена: падает и нагрузка на согласование с ИБ — тот же периметр переиспользуется, а не пересобирается заново.</a:t>
+            </a:r>
+            <a:endParaRPr lang="en-US" sz="1300" dirty="0"/>
+          </a:p>
+        </p:txBody>
+      </p:sp>
+      <p:sp>
+        <p:nvSpPr>
+          <p:cNvPr id="13" name="Text 10"/>
           <p:cNvSpPr/>
           <p:nvPr/>
         </p:nvSpPr>

</xml_diff>